<commit_message>
Final project to submit for course Number 9 (Npower Canada/IBM certification)
</commit_message>
<xml_diff>
--- a/DataAnalystPresentation.pptx
+++ b/DataAnalystPresentation.pptx
@@ -8436,30 +8436,82 @@
               </a:lnSpc>
             </a:pPr>
             <a:r>
-              <a:rPr lang="en-US" sz="3600"/>
+              <a:rPr lang="en-US" sz="3600" dirty="0"/>
               <a:t>Project Title: Technology Trends in the Developer Job Market</a:t>
             </a:r>
             <a:br>
-              <a:rPr lang="en-US" sz="3600"/>
+              <a:rPr lang="en-US" sz="3600" dirty="0"/>
             </a:br>
             <a:br>
-              <a:rPr lang="en-US" sz="3600"/>
+              <a:rPr lang="en-US" sz="3600" dirty="0"/>
             </a:br>
             <a:r>
-              <a:rPr lang="en-US" sz="3600"/>
+              <a:rPr lang="en-US" sz="3600" dirty="0"/>
               <a:t>By: Pierre Marie Ntang</a:t>
             </a:r>
             <a:br>
-              <a:rPr lang="en-US" sz="3600"/>
+              <a:rPr lang="en-US" sz="3600" dirty="0"/>
             </a:br>
             <a:br>
+              <a:rPr lang="en-US" sz="3600" dirty="0"/>
+            </a:br>
+            <a:r>
+              <a:rPr lang="en-US" sz="3600" dirty="0"/>
+              <a:t>Date</a:t>
+            </a:r>
+            <a:r>
               <a:rPr lang="en-US" sz="3600"/>
-            </a:br>
-            <a:r>
-              <a:rPr lang="en-US" sz="3600"/>
-              <a:t>Date: 2025/11/11</a:t>
+              <a:t>: 2025/11/12</a:t>
             </a:r>
             <a:endParaRPr lang="en-US" sz="3600" dirty="0"/>
+          </a:p>
+        </p:txBody>
+      </p:sp>
+      <p:sp>
+        <p:nvSpPr>
+          <p:cNvPr id="6" name="ZoneTexte 5">
+            <a:extLst>
+              <a:ext uri="{FF2B5EF4-FFF2-40B4-BE49-F238E27FC236}">
+                <a16:creationId xmlns:a16="http://schemas.microsoft.com/office/drawing/2014/main" id="{FBB94444-91C7-DA5E-2009-0B637F843C06}"/>
+              </a:ext>
+            </a:extLst>
+          </p:cNvPr>
+          <p:cNvSpPr txBox="1"/>
+          <p:nvPr/>
+        </p:nvSpPr>
+        <p:spPr>
+          <a:xfrm>
+            <a:off x="2641600" y="5824319"/>
+            <a:ext cx="6156960" cy="646331"/>
+          </a:xfrm>
+          <a:prstGeom prst="rect">
+            <a:avLst/>
+          </a:prstGeom>
+          <a:noFill/>
+        </p:spPr>
+        <p:txBody>
+          <a:bodyPr wrap="square">
+            <a:spAutoFit/>
+          </a:bodyPr>
+          <a:lstStyle/>
+          <a:p>
+            <a:r>
+              <a:rPr lang="en-US" dirty="0"/>
+              <a:t>You can find all of the presentation and more materials at </a:t>
+            </a:r>
+            <a:r>
+              <a:rPr lang="en-US" b="1" dirty="0">
+                <a:solidFill>
+                  <a:srgbClr val="00B0F0"/>
+                </a:solidFill>
+              </a:rPr>
+              <a:t>https://github.com/pmntang/Project-for-Data-Science </a:t>
+            </a:r>
+            <a:endParaRPr lang="fr-CA" b="1" dirty="0">
+              <a:solidFill>
+                <a:srgbClr val="00B0F0"/>
+              </a:solidFill>
+            </a:endParaRPr>
           </a:p>
         </p:txBody>
       </p:sp>
@@ -18461,6 +18513,15 @@
 </file>
 
 <file path=customXml/item1.xml><?xml version="1.0" encoding="utf-8"?>
+<?mso-contentType ?>
+<FormTemplates xmlns="http://schemas.microsoft.com/sharepoint/v3/contenttype/forms">
+  <Display>DocumentLibraryForm</Display>
+  <Edit>DocumentLibraryForm</Edit>
+  <New>DocumentLibraryForm</New>
+</FormTemplates>
+</file>
+
+<file path=customXml/item2.xml><?xml version="1.0" encoding="utf-8"?>
 <p:properties xmlns:p="http://schemas.microsoft.com/office/2006/metadata/properties" xmlns:xsi="http://www.w3.org/2001/XMLSchema-instance" xmlns:pc="http://schemas.microsoft.com/office/infopath/2007/PartnerControls">
   <documentManagement>
     <lcf76f155ced4ddcb4097134ff3c332f xmlns="155be751-a274-42e8-93fb-f39d3b9bccc8">
@@ -18470,15 +18531,6 @@
     <AWBlink xmlns="155be751-a274-42e8-93fb-f39d3b9bccc8" xsi:nil="true"/>
   </documentManagement>
 </p:properties>
-</file>
-
-<file path=customXml/item2.xml><?xml version="1.0" encoding="utf-8"?>
-<?mso-contentType ?>
-<FormTemplates xmlns="http://schemas.microsoft.com/sharepoint/v3/contenttype/forms">
-  <Display>DocumentLibraryForm</Display>
-  <Edit>DocumentLibraryForm</Edit>
-  <New>DocumentLibraryForm</New>
-</FormTemplates>
 </file>
 
 <file path=customXml/item3.xml><?xml version="1.0" encoding="utf-8"?>
@@ -18739,6 +18791,14 @@
 </file>
 
 <file path=customXml/itemProps1.xml><?xml version="1.0" encoding="utf-8"?>
+<ds:datastoreItem xmlns:ds="http://schemas.openxmlformats.org/officeDocument/2006/customXml" ds:itemID="{7EFDA260-DDA0-422C-B7AE-778F653FBB36}">
+  <ds:schemaRefs>
+    <ds:schemaRef ds:uri="http://schemas.microsoft.com/sharepoint/v3/contenttype/forms"/>
+  </ds:schemaRefs>
+</ds:datastoreItem>
+</file>
+
+<file path=customXml/itemProps2.xml><?xml version="1.0" encoding="utf-8"?>
 <ds:datastoreItem xmlns:ds="http://schemas.openxmlformats.org/officeDocument/2006/customXml" ds:itemID="{54DA07C5-A406-4A0D-B3E6-3856C94AC7F3}">
   <ds:schemaRefs>
     <ds:schemaRef ds:uri="155be751-a274-42e8-93fb-f39d3b9bccc8"/>
@@ -18751,14 +18811,6 @@
     <ds:schemaRef ds:uri="f80a141d-92ca-4d3d-9308-f7e7b1d44ce8"/>
     <ds:schemaRef ds:uri="http://www.w3.org/XML/1998/namespace"/>
     <ds:schemaRef ds:uri="http://purl.org/dc/terms/"/>
-  </ds:schemaRefs>
-</ds:datastoreItem>
-</file>
-
-<file path=customXml/itemProps2.xml><?xml version="1.0" encoding="utf-8"?>
-<ds:datastoreItem xmlns:ds="http://schemas.openxmlformats.org/officeDocument/2006/customXml" ds:itemID="{7EFDA260-DDA0-422C-B7AE-778F653FBB36}">
-  <ds:schemaRefs>
-    <ds:schemaRef ds:uri="http://schemas.microsoft.com/sharepoint/v3/contenttype/forms"/>
   </ds:schemaRefs>
 </ds:datastoreItem>
 </file>

</xml_diff>